<commit_message>
fix: address review feedback and clean tracked artifacts
Co-authored-by: owenchang1208 <77381502+owenchang1208@users.noreply.github.com>
</commit_message>
<xml_diff>
--- a/output/aegisops_mvp_redraw.pptx
+++ b/output/aegisops_mvp_redraw.pptx
@@ -3208,7 +3208,7 @@
           <a:lstStyle/>
           <a:p>
             <a:r>
-              <a:rPr sz="864" b="1"/>
+              <a:rPr sz="900" b="1"/>
               <a:t>目標：先可觀測，再可評估，最後可治理與自動化</a:t>
             </a:r>
           </a:p>
@@ -3484,7 +3484,7 @@
           <a:lstStyle/>
           <a:p>
             <a:r>
-              <a:rPr sz="720"/>
+              <a:rPr sz="700"/>
               <a:t>Web Portal</a:t>
             </a:r>
           </a:p>
@@ -3532,7 +3532,7 @@
           <a:lstStyle/>
           <a:p>
             <a:r>
-              <a:rPr sz="720"/>
+              <a:rPr sz="700"/>
               <a:t>內部人員</a:t>
             </a:r>
           </a:p>
@@ -3580,7 +3580,7 @@
           <a:lstStyle/>
           <a:p>
             <a:r>
-              <a:rPr sz="720"/>
+              <a:rPr sz="700"/>
               <a:t>開發人員</a:t>
             </a:r>
           </a:p>
@@ -3628,7 +3628,7 @@
           <a:lstStyle/>
           <a:p>
             <a:r>
-              <a:rPr sz="720"/>
+              <a:rPr sz="700"/>
               <a:t>營運 / 維運</a:t>
             </a:r>
           </a:p>
@@ -3676,7 +3676,7 @@
           <a:lstStyle/>
           <a:p>
             <a:r>
-              <a:rPr sz="720"/>
+              <a:rPr sz="700"/>
               <a:t>管理者</a:t>
             </a:r>
           </a:p>
@@ -3724,7 +3724,7 @@
           <a:lstStyle/>
           <a:p>
             <a:r>
-              <a:rPr b="1" sz="864"/>
+              <a:rPr b="1" sz="900"/>
               <a:t>AegisOps 最小可實作架構 (MVP)</a:t>
             </a:r>
           </a:p>
@@ -5413,31 +5413,31 @@
           <a:p>
             <a:pPr algn="ctr"/>
             <a:r>
-              <a:rPr b="1" sz="720"/>
+              <a:rPr b="1" sz="700"/>
               <a:t>Q1：可觀測 (See)</a:t>
             </a:r>
           </a:p>
           <a:p>
             <a:r>
-              <a:rPr sz="612"/>
+              <a:rPr sz="600"/>
               <a:t>建立可觀測與成本基礎能力</a:t>
             </a:r>
           </a:p>
           <a:p>
             <a:r>
-              <a:rPr sz="540"/>
+              <a:rPr sz="550"/>
               <a:t>• 接入 OpenTelemetry、Trace Collector 與 Trace Store</a:t>
             </a:r>
           </a:p>
           <a:p>
             <a:r>
-              <a:rPr sz="540"/>
+              <a:rPr sz="550"/>
               <a:t>• Token / Cost 追蹤</a:t>
             </a:r>
           </a:p>
           <a:p>
             <a:r>
-              <a:rPr sz="540"/>
+              <a:rPr sz="550"/>
               <a:t>• 基礎 Dashboard (Trace / Cost)</a:t>
             </a:r>
           </a:p>
@@ -5529,31 +5529,31 @@
           <a:p>
             <a:pPr algn="ctr"/>
             <a:r>
-              <a:rPr b="1" sz="720"/>
+              <a:rPr b="1" sz="700"/>
               <a:t>Q2：評估與品質 (Measure)</a:t>
             </a:r>
           </a:p>
           <a:p>
             <a:r>
-              <a:rPr sz="612"/>
+              <a:rPr sz="600"/>
               <a:t>建立評估與品質衡量指標</a:t>
             </a:r>
           </a:p>
           <a:p>
             <a:r>
-              <a:rPr sz="540"/>
+              <a:rPr sz="550"/>
               <a:t>• Evaluation Engine (LLM Judge / Rule)</a:t>
             </a:r>
           </a:p>
           <a:p>
             <a:r>
-              <a:rPr sz="540"/>
+              <a:rPr sz="550"/>
               <a:t>• Dataset 管理</a:t>
             </a:r>
           </a:p>
           <a:p>
             <a:r>
-              <a:rPr sz="540"/>
+              <a:rPr sz="550"/>
               <a:t>• Quality Dashboard (品質指標)、Evaluation API</a:t>
             </a:r>
           </a:p>
@@ -5645,37 +5645,37 @@
           <a:p>
             <a:pPr algn="ctr"/>
             <a:r>
-              <a:rPr b="1" sz="720"/>
+              <a:rPr b="1" sz="700"/>
               <a:t>Q3：事件與回饋 (React)</a:t>
             </a:r>
           </a:p>
           <a:p>
             <a:r>
-              <a:rPr sz="612"/>
+              <a:rPr sz="600"/>
               <a:t>建立事件與使用者回饋閉環機制</a:t>
             </a:r>
           </a:p>
           <a:p>
             <a:r>
-              <a:rPr sz="540"/>
+              <a:rPr sz="550"/>
               <a:t>• Incident Center (事件管理)</a:t>
             </a:r>
           </a:p>
           <a:p>
             <a:r>
-              <a:rPr sz="540"/>
+              <a:rPr sz="550"/>
               <a:t>• Feedback Collector (回饋收集)</a:t>
             </a:r>
           </a:p>
           <a:p>
             <a:r>
-              <a:rPr sz="540"/>
+              <a:rPr sz="550"/>
               <a:t>• Risk Detector (風險檢測)</a:t>
             </a:r>
           </a:p>
           <a:p>
             <a:r>
-              <a:rPr sz="540"/>
+              <a:rPr sz="550"/>
               <a:t>• 告警與通知機制</a:t>
             </a:r>
           </a:p>
@@ -5767,37 +5767,37 @@
           <a:p>
             <a:pPr algn="ctr"/>
             <a:r>
-              <a:rPr b="1" sz="720"/>
+              <a:rPr b="1" sz="700"/>
               <a:t>Q4：治理與自動化 (Control)</a:t>
             </a:r>
           </a:p>
           <a:p>
             <a:r>
-              <a:rPr sz="612"/>
+              <a:rPr sz="600"/>
               <a:t>強化治理、發布與自動化能力</a:t>
             </a:r>
           </a:p>
           <a:p>
             <a:r>
-              <a:rPr sz="540"/>
+              <a:rPr sz="550"/>
               <a:t>• Agent / Prompt / Tool 全量管理</a:t>
             </a:r>
           </a:p>
           <a:p>
             <a:r>
-              <a:rPr sz="540"/>
+              <a:rPr sz="550"/>
               <a:t>• Policy &amp; Guardrails 強化</a:t>
             </a:r>
           </a:p>
           <a:p>
             <a:r>
-              <a:rPr sz="540"/>
+              <a:rPr sz="550"/>
               <a:t>• CI/CD Integration</a:t>
             </a:r>
           </a:p>
           <a:p>
             <a:r>
-              <a:rPr sz="540"/>
+              <a:rPr sz="550"/>
               <a:t>• 報表與稽核 (Audit)</a:t>
             </a:r>
           </a:p>

</xml_diff>

<commit_message>
refactor: centralize fonts and correct connector widths
Co-authored-by: owenchang1208 <77381502+owenchang1208@users.noreply.github.com>
</commit_message>
<xml_diff>
--- a/output/aegisops_mvp_redraw.pptx
+++ b/output/aegisops_mvp_redraw.pptx
@@ -5967,7 +5967,7 @@
           <a:prstGeom prst="line">
             <a:avLst/>
           </a:prstGeom>
-          <a:ln w="9144">
+          <a:ln w="9525">
             <a:solidFill>
               <a:srgbClr val="1E88E5"/>
             </a:solidFill>
@@ -6002,7 +6002,7 @@
           <a:prstGeom prst="line">
             <a:avLst/>
           </a:prstGeom>
-          <a:ln w="9144">
+          <a:ln w="9525">
             <a:solidFill>
               <a:srgbClr val="1E88E5"/>
             </a:solidFill>

</xml_diff>